<commit_message>
MVP V2 continuation: G1 expansion + R5 CN + rebuild PDF
Co-authored-by: Cursor <cursoragent@cursor.com>
</commit_message>
<xml_diff>
--- a/03_故事内容/第1卷_觉得奇怪就先观察/正式版/05_出版成果/MVP_V2_20260608/第1单元_MVP路演_V2.0_20260608.pptx
+++ b/03_故事内容/第1卷_觉得奇怪就先观察/正式版/05_出版成果/MVP_V2_20260608/第1单元_MVP路演_V2.0_20260608.pptx
@@ -3784,7 +3784,7 @@
               <a:defRPr sz="1600"/>
             </a:pPr>
             <a:r>
-              <a:t>插图：V2 DEMO 五帧 + G1draft A001</a:t>
+              <a:t>插图：MVP 15 关键帧（7 PNG + 8 G1 PH）· 案01–05 子目录</a:t>
             </a:r>
           </a:p>
           <a:p>
@@ -3800,7 +3800,7 @@
               <a:defRPr sz="1600"/>
             </a:pPr>
             <a:r>
-              <a:t>Gap：G-JP LOCK · 全帧插图 · E06 PASS 待后续</a:t>
+              <a:t>Gap：G-JP LOCK · G-IMG PRODUCT · E06 PASS 待后续</a:t>
             </a:r>
           </a:p>
         </p:txBody>

</xml_diff>

<commit_message>
visual: CLASS 5-2 seating sync — delete outdated illos + update KF/G1
Remove G1DRAFT_REJECT V2-DEMO PNGs and obsolete 4-2 spatial demos; anchor 5年2組 R3·C1/R3·C6 in G-BODY, KF briefs, and MVP build (doc48 manifest).

Co-authored-by: Cursor <cursoragent@cursor.com>
</commit_message>
<xml_diff>
--- a/03_故事内容/第1卷_觉得奇怪就先观察/正式版/05_出版成果/MVP_V2_20260608/第1单元_MVP路演_V2.0_20260608.pptx
+++ b/03_故事内容/第1卷_觉得奇怪就先观察/正式版/05_出版成果/MVP_V2_20260608/第1单元_MVP路演_V2.0_20260608.pptx
@@ -3232,7 +3232,7 @@
               <a:defRPr sz="1600"/>
             </a:pPr>
             <a:r>
-              <a:t>Illus: G1draft / V2-DEMO depth anchor</a:t>
+              <a:t>Illus: G1draft / V2 depth anchor · DEMO removed 2026-06-08</a:t>
             </a:r>
           </a:p>
           <a:p>
@@ -3344,7 +3344,7 @@
               <a:defRPr sz="1600"/>
             </a:pPr>
             <a:r>
-              <a:t>Illus: G1draft / V2-DEMO depth anchor</a:t>
+              <a:t>Illus: G1draft / V2 depth anchor · DEMO removed 2026-06-08</a:t>
             </a:r>
           </a:p>
           <a:p>
@@ -3456,7 +3456,7 @@
               <a:defRPr sz="1600"/>
             </a:pPr>
             <a:r>
-              <a:t>Illus: G1draft / V2-DEMO depth anchor</a:t>
+              <a:t>Illus: G1draft / V2 depth anchor · DEMO removed 2026-06-08</a:t>
             </a:r>
           </a:p>
           <a:p>
@@ -3568,7 +3568,7 @@
               <a:defRPr sz="1600"/>
             </a:pPr>
             <a:r>
-              <a:t>Illus: G1draft / V2-DEMO depth anchor</a:t>
+              <a:t>Illus: G1draft / V2 depth anchor · DEMO removed 2026-06-08</a:t>
             </a:r>
           </a:p>
           <a:p>
@@ -3680,7 +3680,7 @@
               <a:defRPr sz="1600"/>
             </a:pPr>
             <a:r>
-              <a:t>Illus: G1draft / V2-DEMO depth anchor</a:t>
+              <a:t>Illus: G1draft / V2 depth anchor · DEMO removed 2026-06-08</a:t>
             </a:r>
           </a:p>
           <a:p>
@@ -3784,7 +3784,7 @@
               <a:defRPr sz="1600"/>
             </a:pPr>
             <a:r>
-              <a:t>插图：MVP 15 关键帧（7 PNG + 8 G1 PH）· 案01–05 子目录</a:t>
+              <a:t>插图：MVP 10 关键帧（1 G1 c01 + 9 G1 PH）· CLASS_5-2 座席同步 · 案01–05 子目录</a:t>
             </a:r>
           </a:p>
           <a:p>

</xml_diff>